<commit_message>
Make market overview item and country first
</commit_message>
<xml_diff>
--- a/docs/fastcpi_user_guide_2026-09-09.pptx
+++ b/docs/fastcpi_user_guide_2026-09-09.pptx
@@ -3809,7 +3809,15 @@
             </a:pPr>
             <a:r>
               <a:rPr/>
-              <a:t>The static Plotly dashboard summarizes observed coverage, base-100 price-index series and comparable EUR distributions. Chat questions can also stream Plotly views into the conversation.</a:t>
+              <a:t>The default </a:t>
+            </a:r>
+            <a:r>
+              <a:rPr b="1"/>
+              <a:t>Within one country / Dans un même pays</a:t>
+            </a:r>
+            <a:r>
+              <a:rPr/>
+              <a:t> view starts with one selected catalogue item and one country. It compares the latest comparable observation for each distinct supplier offer, showing the lowest price, median, observed spread and clickable source evidence. This is the primary procurement review because prices from competing suppliers in the same country are usually more directly comparable.</a:t>
             </a:r>
           </a:p>
           <a:p>
@@ -3818,7 +3826,15 @@
             </a:pPr>
             <a:r>
               <a:rPr/>
-              <a:t>Read every chart with its sample size and freshness. Pilot indices are derived from observed asking prices; they do not yet have official statistical weights, seasonal treatment, confidence intervals or a formal revision policy.</a:t>
+              <a:t>Use the item and country selectors to change the benchmark. Open </a:t>
+            </a:r>
+            <a:r>
+              <a:rPr b="1"/>
+              <a:t>Across the EU / Dans l’Union européenne</a:t>
+            </a:r>
+            <a:r>
+              <a:rPr/>
+              <a:t> only as a secondary review: it plots each observed country’s median and price range, then preserves the underlying supplier links below the chart.</a:t>
             </a:r>
           </a:p>
           <a:p>
@@ -3827,7 +3843,7 @@
             </a:pPr>
             <a:r>
               <a:rPr/>
-              <a:t>Use these charts to find gaps, changes and outliers—not as official inflation measures.</a:t>
+              <a:t>Repeated captures of the same offer do not receive extra weight: the dashboard uses its latest observation. Read every result with its source count, freshness, unit, VAT/delivery warnings and coverage note. The spread remains an observed web sample—not an official inflation measure or a claim of complete market coverage.</a:t>
             </a:r>
           </a:p>
         </p:txBody>
@@ -4093,7 +4109,17 @@
             </a:pPr>
             <a:r>
               <a:rPr/>
-              <a:t>Core resources search persisted observations, run live observations, resolve CPV descendants, read market coverage and indices, manage user watchlists and access catalog items. Live discovery requires a stronger scope than read-only access.</a:t>
+              <a:t>Core resources search persisted observations, run live observations, resolve CPV descendants, read market coverage and indices, manage user watchlists and access catalog items. Use </a:t>
+            </a:r>
+            <a:r>
+              <a:rPr>
+                <a:latin typeface="Courier"/>
+              </a:rPr>
+              <a:t>GET /items/{item_id}/price-variance?market=FR</a:t>
+            </a:r>
+            <a:r>
+              <a:rPr/>
+              <a:t> for the same latest-offer country benchmark and secondary EU context shown by the dashboard. Live discovery requires a stronger scope than read-only access.</a:t>
             </a:r>
           </a:p>
         </p:txBody>

</xml_diff>

<commit_message>
Ship durable monitoring and MCP alpha
</commit_message>
<xml_diff>
--- a/docs/fastcpi_user_guide_2026-09-09.pptx
+++ b/docs/fastcpi_user_guide_2026-09-09.pptx
@@ -3403,7 +3403,7 @@
       </p:sp>
       <p:pic>
         <p:nvPicPr>
-          <p:cNvPr descr="../screenshots/07-french-watchlists.png" id="0" name="Picture 1"/>
+          <p:cNvPr descr="../screenshots/13-french-watchlist-management.png" id="0" name="Picture 1"/>
           <p:cNvPicPr>
             <a:picLocks noGrp="1" noChangeAspect="1"/>
           </p:cNvPicPr>
@@ -3417,8 +3417,8 @@
         </p:blipFill>
         <p:spPr bwMode="auto">
           <a:xfrm>
-            <a:off x="2260600" y="1193800"/>
-            <a:ext cx="4610100" cy="2882900"/>
+            <a:off x="2006600" y="1193800"/>
+            <a:ext cx="5130800" cy="2882900"/>
           </a:xfrm>
           <a:prstGeom prst="rect">
             <a:avLst/>
@@ -3519,7 +3519,15 @@
             </a:pPr>
             <a:r>
               <a:rPr/>
-              <a:t>Starter watches are user-specific. Deleting one is respected; it is not recreated on every login. The current browser UI creates and lists watches. Edit, pause, delete and run-now controls are the next monitoring slice; those mutations already exist in the REST API where noted in OpenAPI.</a:t>
+              <a:t>Starter watches are user-specific. Deleting one is respected; it is not recreated on every login. Create your own goods or services dynamically, optionally link them to a catalogue item, and select one or more markets. Each watch can be edited, paused/resumed, deleted or run immediately. Open </a:t>
+            </a:r>
+            <a:r>
+              <a:rPr b="1"/>
+              <a:t>Evidence and run history / Preuves et historique des analyses</a:t>
+            </a:r>
+            <a:r>
+              <a:rPr/>
+              <a:t> to inspect durable queued, running, partial, successful or failed scan states and the latest clickable source evidence.</a:t>
             </a:r>
           </a:p>
         </p:txBody>
@@ -3573,7 +3581,7 @@
       </p:sp>
       <p:pic>
         <p:nvPicPr>
-          <p:cNvPr descr="../screenshots/05-french-daily-scan.png" id="0" name="Picture 1"/>
+          <p:cNvPr descr="../screenshots/14-french-daily-scan-runs.png" id="0" name="Picture 1"/>
           <p:cNvPicPr>
             <a:picLocks noGrp="1" noChangeAspect="1"/>
           </p:cNvPicPr>
@@ -3587,8 +3595,8 @@
         </p:blipFill>
         <p:spPr bwMode="auto">
           <a:xfrm>
-            <a:off x="2260600" y="1193800"/>
-            <a:ext cx="4610100" cy="2882900"/>
+            <a:off x="2006600" y="1193800"/>
+            <a:ext cx="5130800" cy="2882900"/>
           </a:xfrm>
           <a:prstGeom prst="rect">
             <a:avLst/>
@@ -3651,7 +3659,7 @@
             </a:pPr>
             <a:r>
               <a:rPr/>
-              <a:t>Daily Scan shows active-watch count, 24-hour observations and threshold events. Each watch shows its latest source-backed observation or </a:t>
+              <a:t>Daily Scan shows active-watch count, 24-hour scan runs, observations, threshold events and failed runs. Each watch shows its latest source-backed observation or </a:t>
             </a:r>
             <a:r>
               <a:rPr b="1"/>
@@ -3659,7 +3667,7 @@
             </a:r>
             <a:r>
               <a:rPr/>
-              <a:t>.</a:t>
+              <a:t>. Recent runs link back to their per-watch evidence history.</a:t>
             </a:r>
           </a:p>
           <a:p>
@@ -3677,7 +3685,7 @@
             </a:pPr>
             <a:r>
               <a:rPr/>
-              <a:t>The pilot scheduler currently runs inside the application process. Durable queued scan runs, leases, retry state, domain throttling and cost quotas are the priority next slice.</a:t>
+              <a:t>Scan requests are durable PostgreSQL jobs with idempotency keys, leases, bounded retries and per-market outcomes. Production worker separation, domain throttling and one shared usage ledger across all paid discovery paths are the next operational slice.</a:t>
             </a:r>
           </a:p>
         </p:txBody>
@@ -4109,7 +4117,7 @@
             </a:pPr>
             <a:r>
               <a:rPr/>
-              <a:t>Core resources search persisted observations, run live observations, resolve CPV descendants, read market coverage and indices, manage user watchlists and access catalog items. Use </a:t>
+              <a:t>Core resources search persisted observations, queue live observation jobs, resolve CPV descendants, read market coverage and indices, manage user watchlists and access catalog items. Use </a:t>
             </a:r>
             <a:r>
               <a:rPr>
@@ -4119,7 +4127,27 @@
             </a:r>
             <a:r>
               <a:rPr/>
-              <a:t> for the same latest-offer country benchmark and secondary EU context shown by the dashboard. Live discovery requires a stronger scope than read-only access.</a:t>
+              <a:t> for the same latest-offer country benchmark and secondary EU context shown by the dashboard. Prefer </a:t>
+            </a:r>
+            <a:r>
+              <a:rPr>
+                <a:latin typeface="Courier"/>
+              </a:rPr>
+              <a:t>POST /observation-jobs</a:t>
+            </a:r>
+            <a:r>
+              <a:rPr/>
+              <a:t> with an </a:t>
+            </a:r>
+            <a:r>
+              <a:rPr>
+                <a:latin typeface="Courier"/>
+              </a:rPr>
+              <a:t>Idempotency-Key</a:t>
+            </a:r>
+            <a:r>
+              <a:rPr/>
+              <a:t>, then poll its returned status URL; it has per-user daily quota headers. Live discovery requires a stronger scope than read-only access.</a:t>
             </a:r>
           </a:p>
         </p:txBody>
@@ -4288,17 +4316,35 @@
             </a:pPr>
             <a:r>
               <a:rPr/>
-              <a:t>The planned MCP alpha is read-only: observation search, CPV lookup, market overview, indices, catalog items and methodology resources over </a:t>
+              <a:t>The MCP alpha is live at </a:t>
+            </a:r>
+            <a:r>
+              <a:rPr b="1"/>
+              <a:t>https://cpi.fastsme.com/mcp/</a:t>
+            </a:r>
+            <a:r>
+              <a:rPr/>
+              <a:t> over Streamable HTTP. Pass the same key as </a:t>
             </a:r>
             <a:r>
               <a:rPr>
                 <a:latin typeface="Courier"/>
               </a:rPr>
-              <a:t>POST /mcp</a:t>
-            </a:r>
-            <a:r>
-              <a:rPr/>
-              <a:t>. It will reuse FastCPI’s service layer, tenant isolation and provenance schemas. OAuth protected-resource discovery and consent precede any live crawl or watchlist write tool.</a:t>
+              <a:t>Authorization: Bearer fcpi_…</a:t>
+            </a:r>
+            <a:r>
+              <a:rPr/>
+              <a:t>. LLM clients can discover six read-only tools: catalogue search, CPV search, same-country price variance, country overview, tenant-scoped watchlists and scan-run status, plus </a:t>
+            </a:r>
+            <a:r>
+              <a:rPr>
+                <a:latin typeface="Courier"/>
+              </a:rPr>
+              <a:t>fastcpi://methodology</a:t>
+            </a:r>
+            <a:r>
+              <a:rPr/>
+              <a:t>. The official SDK provides current and 2025-era protocol compatibility; OAuth authorization and consent remain the next access-control phase. No live crawl or watchlist mutation is exposed through MCP.</a:t>
             </a:r>
           </a:p>
           <a:p>
@@ -4467,7 +4513,7 @@
             </a:pPr>
             <a:r>
               <a:rPr/>
-              <a:t>Current gaps include JavaScript-only/PDF/quote-only sources, shallow supplier-specific parsers, incomplete pack/VAT/shipping/MOQ normalization and process-local scheduling. Report questionable evidence rather than silently treating it as comparable.</a:t>
+              <a:t>Current gaps include JavaScript-only/PDF/quote-only sources, shallow supplier-specific parsers, incomplete pack/VAT/shipping/MOQ normalization, a not-yet-separated production worker and transitional MCP API-key authentication. Report questionable evidence rather than silently treating it as comparable.</a:t>
             </a:r>
           </a:p>
           <a:p>

</xml_diff>